<commit_message>
Drop hosted demo; add 'Run it yourself' slide and reproduce-from-clone docs
- Deck: Hugging Face link removed; slide 7 now lists code and data; new slide 8 shows the
  clone -> install -> configure -> evaluate/predict commands (verified in a fresh clone on CPU:
  88.6% test top-1 reproduced in ~25 s)
- README: Hugging Face section removed; reproduce command (evaluate.py --weights) added
- PROJECT_STATUS / CHANGELOG / deployment.md updated to match

Co-Authored-By: Claude Opus 5.5 <noreply@anthropic.com>
</commit_message>
<xml_diff>
--- a/docs/presentation/Vision_Based_Grasp_Planner.pptx
+++ b/docs/presentation/Vision_Based_Grasp_Planner.pptx
@@ -12,9 +12,10 @@
     <p:sldId id="260" r:id="rId6"/>
     <p:sldId id="261" r:id="rId7"/>
     <p:sldId id="262" r:id="rId8"/>
+    <p:sldId id="263" r:id="rId9"/>
   </p:sldIdLst>
   <p:notesMasterIdLst>
-    <p:notesMasterId r:id="rId9"/>
+    <p:notesMasterId r:id="rId10"/>
   </p:notesMasterIdLst>
   <p:sldSz cx="9144000" cy="5143500"/>
   <p:notesSz cx="5143500" cy="9144000"/>
@@ -113,31 +114,32 @@
   <p:extLst>
     <p:ext uri="{521415D9-36F7-43E2-AB2F-B90AF26B5E84}">
       <p14:sectionLst xmlns:p14="http://schemas.microsoft.com/office/powerpoint/2010/main">
-        <p14:section name="Introduction" id="{7ba815fc-c218-2851-5e95-70536150d98b}">
+        <p14:section name="Introduction" id="{ecc5e1fc-365a-b00f-caec-f4244575a50c}">
           <p14:sldIdLst>
             <p14:sldId id="256"/>
           </p14:sldIdLst>
         </p14:section>
-        <p14:section name="Approach" id="{f8314f33-89cb-b2be-774a-4e7d510e8328}">
+        <p14:section name="Approach" id="{d1fc3ada-62f7-6d30-402e-8eecc0c64faa}">
           <p14:sldIdLst>
             <p14:sldId id="257"/>
             <p14:sldId id="258"/>
           </p14:sldIdLst>
         </p14:section>
-        <p14:section name="Training" id="{60f3c0b3-1495-e5d1-2dbc-8009e3f311af}">
+        <p14:section name="Training" id="{1b0be4c5-04ee-8039-ff7f-a9bd2412b2ea}">
           <p14:sldIdLst>
             <p14:sldId id="259"/>
           </p14:sldIdLst>
         </p14:section>
-        <p14:section name="Results" id="{f2dae25b-6cd1-c4e0-2a3c-49dc5d96aaf3}">
+        <p14:section name="Results" id="{d3e3a246-3bd0-a64c-73b9-eec0e916a596}">
           <p14:sldIdLst>
             <p14:sldId id="260"/>
             <p14:sldId id="261"/>
           </p14:sldIdLst>
         </p14:section>
-        <p14:section name="Try it" id="{4549e7df-bc64-bc7b-4236-0b7860e1b87a}">
+        <p14:section name="Try it" id="{8a91af1a-3759-7f53-1201-a5ea5b7c7f57}">
           <p14:sldIdLst>
             <p14:sldId id="262"/>
+            <p14:sldId id="263"/>
           </p14:sldIdLst>
         </p14:section>
       </p14:sectionLst>
@@ -1355,7 +1357,7 @@
           <a:p>
             <a:r>
               <a:rPr lang="en-US" dirty="0"/>
-              <a:t>Links: live demo https://huggingface.co/spaces/btechbillu/Vission-Based-grasper (Hugging Face Space, runs on CPU, includes four clickable test scenes); code and report https://github.com/harshultyagi/vision_based_gripper; dataset https://www.kaggle.com/datasets/oneoneliu/cornell-grasp. Limitations: trained only on single-object Cornell scenes from one camera setup; predicts 2-D image grasps (no 3-D pose, calibration or collision checking); not validated on physical hardware.</a:t>
+              <a:t>Code, trained models and the full technical report: https://github.com/harshultyagi/vision_based_gripper. Dataset: https://www.kaggle.com/datasets/oneoneliu/cornell-grasp. Limitations: trained only on single-object Cornell scenes from one camera setup; predicts 2-D image grasps (no 3-D pose, calibration or collision checking); not validated on physical hardware.</a:t>
             </a:r>
             <a:endParaRPr lang="en-US" dirty="0"/>
           </a:p>
@@ -1379,6 +1381,94 @@
             <a:fld id="{F7021451-1387-4CA6-816F-3879F97B5CBC}" type="slidenum">
               <a:rPr lang="en-US"/>
               <a:t>7</a:t>
+            </a:fld>
+            <a:endParaRPr lang="en-US"/>
+          </a:p>
+        </p:txBody>
+      </p:sp>
+    </p:spTree>
+    <p:extLst>
+      <p:ext uri="{BB962C8B-B14F-4D97-AF65-F5344CB8AC3E}">
+        <p14:creationId xmlns:p14="http://schemas.microsoft.com/office/powerpoint/2010/main" val="1024086991"/>
+      </p:ext>
+    </p:extLst>
+  </p:cSld>
+  <p:clrMapOvr>
+    <a:masterClrMapping/>
+  </p:clrMapOvr>
+</p:notes>
+</file>
+
+<file path=ppt/notesSlides/notesSlide8.xml><?xml version="1.0" encoding="utf-8"?>
+<p:notes xmlns:a="http://schemas.openxmlformats.org/drawingml/2006/main" xmlns:r="http://schemas.openxmlformats.org/officeDocument/2006/relationships" xmlns:p="http://schemas.openxmlformats.org/presentationml/2006/main">
+  <p:cSld>
+    <p:spTree>
+      <p:nvGrpSpPr>
+        <p:cNvPr id="1" name=""/>
+        <p:cNvGrpSpPr/>
+        <p:nvPr/>
+      </p:nvGrpSpPr>
+      <p:grpSpPr>
+        <a:xfrm>
+          <a:off x="0" y="0"/>
+          <a:ext cx="0" cy="0"/>
+          <a:chOff x="0" y="0"/>
+          <a:chExt cx="0" cy="0"/>
+        </a:xfrm>
+      </p:grpSpPr>
+      <p:sp>
+        <p:nvSpPr>
+          <p:cNvPr id="2" name="Slide Image Placeholder 1"/>
+          <p:cNvSpPr>
+            <a:spLocks noGrp="1" noRot="1" noChangeAspect="1"/>
+          </p:cNvSpPr>
+          <p:nvPr>
+            <p:ph type="sldImg"/>
+          </p:nvPr>
+        </p:nvSpPr>
+        <p:spPr/>
+      </p:sp>
+      <p:sp>
+        <p:nvSpPr>
+          <p:cNvPr id="3" name="Notes Placeholder 2"/>
+          <p:cNvSpPr>
+            <a:spLocks noGrp="1"/>
+          </p:cNvSpPr>
+          <p:nvPr>
+            <p:ph type="body" idx="1"/>
+          </p:nvPr>
+        </p:nvSpPr>
+        <p:spPr/>
+        <p:txBody>
+          <a:bodyPr/>
+          <a:lstStyle/>
+          <a:p>
+            <a:r>
+              <a:rPr lang="en-US" dirty="0"/>
+              <a:t>Checked by cloning the repository into a fresh folder, installing with these commands and running on the CPU with the GPU hidden: evaluate.py reproduced the 88.6% test top-1 (95.5% top-5) in about 25 seconds, and predict.py printed ranked grasps. DATA stands for the unzipped dataset folder (the one containing 01 to 10); set the same path as dataset_root in configs/local.yaml. evaluate.py needs the dataset; predict.py only needs an image. With an NVIDIA GPU, install the CUDA build of PyTorch from pytorch.org instead of the plain pip command. Optional: python app/app.py starts the web interface at http://127.0.0.1:7860; python scripts/train.py --config configs/experiment_configs/grconvnet_rgbd_image.yaml retrains the model (about 10 minutes on a laptop GPU).</a:t>
+            </a:r>
+            <a:endParaRPr lang="en-US" dirty="0"/>
+          </a:p>
+        </p:txBody>
+      </p:sp>
+      <p:sp>
+        <p:nvSpPr>
+          <p:cNvPr id="4" name="Slide Number Placeholder 3"/>
+          <p:cNvSpPr>
+            <a:spLocks noGrp="1"/>
+          </p:cNvSpPr>
+          <p:nvPr>
+            <p:ph type="sldNum" sz="quarter" idx="10"/>
+          </p:nvPr>
+        </p:nvSpPr>
+        <p:spPr/>
+        <p:txBody>
+          <a:bodyPr/>
+          <a:lstStyle/>
+          <a:p>
+            <a:fld id="{F7021451-1387-4CA6-816F-3879F97B5CBC}" type="slidenum">
+              <a:rPr lang="en-US"/>
+              <a:t>8</a:t>
             </a:fld>
             <a:endParaRPr lang="en-US"/>
           </a:p>
@@ -5403,7 +5493,7 @@
                   <a:schemeClr val="bg1"/>
                 </a:solidFill>
               </a:rPr>
-              <a:t>Try it yourself</a:t>
+              <a:t>Code and data</a:t>
             </a:r>
             <a:endParaRPr lang="en-US" sz="3200" dirty="0"/>
           </a:p>
@@ -5417,12 +5507,12 @@
         </p:nvSpPr>
         <p:spPr>
           <a:xfrm>
-            <a:off x="457200" y="1188720"/>
-            <a:ext cx="8229600" cy="822960"/>
+            <a:off x="457200" y="1417320"/>
+            <a:ext cx="8229600" cy="914400"/>
           </a:xfrm>
           <a:prstGeom prst="roundRect">
             <a:avLst>
-              <a:gd name="adj" fmla="val 11111"/>
+              <a:gd name="adj" fmla="val 10000"/>
             </a:avLst>
           </a:prstGeom>
           <a:solidFill>
@@ -5439,7 +5529,7 @@
         </p:nvSpPr>
         <p:spPr>
           <a:xfrm>
-            <a:off x="658368" y="1325880"/>
+            <a:off x="658368" y="1600200"/>
             <a:ext cx="548640" cy="548640"/>
           </a:xfrm>
           <a:prstGeom prst="ellipse">
@@ -5467,7 +5557,7 @@
         </p:blipFill>
         <p:spPr>
           <a:xfrm>
-            <a:off x="795528" y="1463040"/>
+            <a:off x="795528" y="1737360"/>
             <a:ext cx="274320" cy="274320"/>
           </a:xfrm>
           <a:prstGeom prst="rect">
@@ -5483,8 +5573,8 @@
         </p:nvSpPr>
         <p:spPr>
           <a:xfrm>
-            <a:off x="1417320" y="1280160"/>
-            <a:ext cx="2926080" cy="640080"/>
+            <a:off x="1417320" y="1554480"/>
+            <a:ext cx="3291840" cy="640080"/>
           </a:xfrm>
           <a:prstGeom prst="rect">
             <a:avLst/>
@@ -5505,7 +5595,7 @@
                   <a:schemeClr val="bg1"/>
                 </a:solidFill>
               </a:rPr>
-              <a:t>Live demo</a:t>
+              <a:t>Code, trained models and full report</a:t>
             </a:r>
             <a:endParaRPr lang="en-US" sz="1600" dirty="0"/>
           </a:p>
@@ -5519,7 +5609,7 @@
                   <a:schemeClr val="bg2"/>
                 </a:solidFill>
               </a:rPr>
-              <a:t>Upload a photo or click an example</a:t>
+              <a:t>Everything needed to reproduce the results</a:t>
             </a:r>
             <a:endParaRPr lang="en-US" sz="1600" dirty="0"/>
           </a:p>
@@ -5533,8 +5623,8 @@
         </p:nvSpPr>
         <p:spPr>
           <a:xfrm>
-            <a:off x="4389120" y="1280160"/>
-            <a:ext cx="4114800" cy="640080"/>
+            <a:off x="4663440" y="1554480"/>
+            <a:ext cx="3840480" cy="640080"/>
           </a:xfrm>
           <a:prstGeom prst="rect">
             <a:avLst/>
@@ -5554,7 +5644,7 @@
                 <a:solidFill>
                   <a:schemeClr val="accent1"/>
                 </a:solidFill>
-                <a:hlinkClick r:id="rId2" invalidUrl="" action="" tgtFrame="" tooltip="https://huggingface.co/spaces/btechbillu/Vission-Based-grasper" history="1" highlightClick="0" endSnd="0">
+                <a:hlinkClick r:id="rId2" invalidUrl="" action="" tgtFrame="" tooltip="https://github.com/harshultyagi/vision_based_gripper" history="1" highlightClick="0" endSnd="0">
                   <a:extLst>
                     <a:ext uri="{A12FA001-AC4F-418D-AE19-62706E023703}">
                       <ahyp:hlinkClr xmlns:ahyp="http://schemas.microsoft.com/office/drawing/2018/hyperlinkcolor" val="tx"/>
@@ -5562,7 +5652,7 @@
                   </a:extLst>
                 </a:hlinkClick>
               </a:rPr>
-              <a:t>huggingface.co/spaces/btechbillu/Vission-Based-grasper</a:t>
+              <a:t>github.com/harshultyagi/vision_based_gripper</a:t>
             </a:r>
             <a:endParaRPr lang="en-US" sz="1300" dirty="0"/>
           </a:p>
@@ -5576,12 +5666,12 @@
         </p:nvSpPr>
         <p:spPr>
           <a:xfrm>
-            <a:off x="457200" y="2176272"/>
-            <a:ext cx="8229600" cy="822960"/>
+            <a:off x="457200" y="2560320"/>
+            <a:ext cx="8229600" cy="914400"/>
           </a:xfrm>
           <a:prstGeom prst="roundRect">
             <a:avLst>
-              <a:gd name="adj" fmla="val 11111"/>
+              <a:gd name="adj" fmla="val 10000"/>
             </a:avLst>
           </a:prstGeom>
           <a:solidFill>
@@ -5598,7 +5688,7 @@
         </p:nvSpPr>
         <p:spPr>
           <a:xfrm>
-            <a:off x="658368" y="2313432"/>
+            <a:off x="658368" y="2743200"/>
             <a:ext cx="548640" cy="548640"/>
           </a:xfrm>
           <a:prstGeom prst="ellipse">
@@ -5626,7 +5716,7 @@
         </p:blipFill>
         <p:spPr>
           <a:xfrm>
-            <a:off x="795528" y="2450592"/>
+            <a:off x="795528" y="2880360"/>
             <a:ext cx="274320" cy="274320"/>
           </a:xfrm>
           <a:prstGeom prst="rect">
@@ -5642,8 +5732,8 @@
         </p:nvSpPr>
         <p:spPr>
           <a:xfrm>
-            <a:off x="1417320" y="2267712"/>
-            <a:ext cx="2926080" cy="640080"/>
+            <a:off x="1417320" y="2697480"/>
+            <a:ext cx="3291840" cy="640080"/>
           </a:xfrm>
           <a:prstGeom prst="rect">
             <a:avLst/>
@@ -5664,7 +5754,7 @@
                   <a:schemeClr val="bg1"/>
                 </a:solidFill>
               </a:rPr>
-              <a:t>Code and full report</a:t>
+              <a:t>Dataset</a:t>
             </a:r>
             <a:endParaRPr lang="en-US" sz="1600" dirty="0"/>
           </a:p>
@@ -5678,7 +5768,7 @@
                   <a:schemeClr val="bg2"/>
                 </a:solidFill>
               </a:rPr>
-              <a:t>Training, evaluation, tests, 13-chapter report</a:t>
+              <a:t>Cornell Grasping Dataset (Kaggle copy)</a:t>
             </a:r>
             <a:endParaRPr lang="en-US" sz="1600" dirty="0"/>
           </a:p>
@@ -5692,8 +5782,8 @@
         </p:nvSpPr>
         <p:spPr>
           <a:xfrm>
-            <a:off x="4389120" y="2267712"/>
-            <a:ext cx="4114800" cy="640080"/>
+            <a:off x="4663440" y="2697480"/>
+            <a:ext cx="3840480" cy="640080"/>
           </a:xfrm>
           <a:prstGeom prst="rect">
             <a:avLst/>
@@ -5713,7 +5803,7 @@
                 <a:solidFill>
                   <a:schemeClr val="accent1"/>
                 </a:solidFill>
-                <a:hlinkClick r:id="rId4" invalidUrl="" action="" tgtFrame="" tooltip="https://github.com/harshultyagi/vision_based_gripper" history="1" highlightClick="0" endSnd="0">
+                <a:hlinkClick r:id="rId4" invalidUrl="" action="" tgtFrame="" tooltip="https://www.kaggle.com/datasets/oneoneliu/cornell-grasp" history="1" highlightClick="0" endSnd="0">
                   <a:extLst>
                     <a:ext uri="{A12FA001-AC4F-418D-AE19-62706E023703}">
                       <ahyp:hlinkClr xmlns:ahyp="http://schemas.microsoft.com/office/drawing/2018/hyperlinkcolor" val="tx"/>
@@ -5721,7 +5811,7 @@
                   </a:extLst>
                 </a:hlinkClick>
               </a:rPr>
-              <a:t>github.com/harshultyagi/vision_based_gripper</a:t>
+              <a:t>kaggle.com/datasets/oneoneliu/cornell-grasp</a:t>
             </a:r>
             <a:endParaRPr lang="en-US" sz="1300" dirty="0"/>
           </a:p>
@@ -5729,18 +5819,117 @@
       </p:sp>
       <p:sp>
         <p:nvSpPr>
-          <p:cNvPr id="13" name="link-card-3"/>
+          <p:cNvPr id="13" name="limits"/>
+          <p:cNvSpPr txBox="1"/>
+          <p:nvPr/>
+        </p:nvSpPr>
+        <p:spPr>
+          <a:xfrm>
+            <a:off x="457200" y="4160520"/>
+            <a:ext cx="8229600" cy="320040"/>
+          </a:xfrm>
+          <a:prstGeom prst="rect">
+            <a:avLst/>
+          </a:prstGeom>
+          <a:noFill/>
+          <a:ln/>
+        </p:spPr>
+        <p:txBody>
+          <a:bodyPr wrap="square" lIns="0" tIns="0" rIns="0" bIns="0" rtlCol="0" anchor="ctr"/>
+          <a:lstStyle/>
+          <a:p>
+            <a:pPr indent="0" marL="0">
+              <a:buNone/>
+            </a:pPr>
+            <a:r>
+              <a:rPr lang="en-US" sz="1200" i="1" dirty="0">
+                <a:solidFill>
+                  <a:schemeClr val="accent5"/>
+                </a:solidFill>
+              </a:rPr>
+              <a:t>Limits: single-object scenes · 2-D image grasps only · not yet tested on a real robot</a:t>
+            </a:r>
+            <a:endParaRPr lang="en-US" sz="1200" dirty="0"/>
+          </a:p>
+        </p:txBody>
+      </p:sp>
+    </p:spTree>
+  </p:cSld>
+  <p:clrMapOvr>
+    <a:masterClrMapping/>
+  </p:clrMapOvr>
+</p:sld>
+</file>
+
+<file path=ppt/slides/slide8.xml><?xml version="1.0" encoding="utf-8"?>
+<p:sld xmlns:a="http://schemas.openxmlformats.org/drawingml/2006/main" xmlns:r="http://schemas.openxmlformats.org/officeDocument/2006/relationships" xmlns:p="http://schemas.openxmlformats.org/presentationml/2006/main">
+  <p:cSld name="Slide 8">
+    <p:spTree>
+      <p:nvGrpSpPr>
+        <p:cNvPr id="1" name=""/>
+        <p:cNvGrpSpPr/>
+        <p:nvPr/>
+      </p:nvGrpSpPr>
+      <p:grpSpPr>
+        <a:xfrm>
+          <a:off x="0" y="0"/>
+          <a:ext cx="0" cy="0"/>
+          <a:chOff x="0" y="0"/>
+          <a:chExt cx="0" cy="0"/>
+        </a:xfrm>
+      </p:grpSpPr>
+      <p:sp>
+        <p:nvSpPr>
+          <p:cNvPr id="2" name="Text 0"/>
           <p:cNvSpPr/>
-          <p:nvPr/>
-        </p:nvSpPr>
-        <p:spPr>
-          <a:xfrm>
-            <a:off x="457200" y="3163824"/>
-            <a:ext cx="8229600" cy="822960"/>
+          <p:nvPr>
+            <p:ph idx="100" type="title" hasCustomPrompt="1"/>
+          </p:nvPr>
+        </p:nvSpPr>
+        <p:spPr>
+          <a:xfrm>
+            <a:off x="457200" y="320040"/>
+            <a:ext cx="8229600" cy="640080"/>
+          </a:xfrm>
+          <a:prstGeom prst="rect">
+            <a:avLst/>
+          </a:prstGeom>
+          <a:noFill/>
+          <a:ln/>
+        </p:spPr>
+        <p:txBody>
+          <a:bodyPr wrap="square" lIns="0" tIns="0" rIns="0" bIns="0" rtlCol="0" anchor="ctr"/>
+          <a:lstStyle/>
+          <a:p>
+            <a:pPr indent="0" marL="0">
+              <a:buNone/>
+            </a:pPr>
+            <a:r>
+              <a:rPr lang="en-US" sz="3200" b="1" dirty="0">
+                <a:solidFill>
+                  <a:schemeClr val="bg1"/>
+                </a:solidFill>
+              </a:rPr>
+              <a:t>Run it yourself</a:t>
+            </a:r>
+            <a:endParaRPr lang="en-US" sz="3200" dirty="0"/>
+          </a:p>
+        </p:txBody>
+      </p:sp>
+      <p:sp>
+        <p:nvSpPr>
+          <p:cNvPr id="3" name="code-panel"/>
+          <p:cNvSpPr/>
+          <p:nvPr/>
+        </p:nvSpPr>
+        <p:spPr>
+          <a:xfrm>
+            <a:off x="457200" y="1051560"/>
+            <a:ext cx="8229600" cy="2606040"/>
           </a:xfrm>
           <a:prstGeom prst="roundRect">
             <a:avLst>
-              <a:gd name="adj" fmla="val 11111"/>
+              <a:gd name="adj" fmla="val 3509"/>
             </a:avLst>
           </a:prstGeom>
           <a:solidFill>
@@ -5751,58 +5940,14 @@
       </p:sp>
       <p:sp>
         <p:nvSpPr>
-          <p:cNvPr id="14" name="link-circle-3"/>
-          <p:cNvSpPr/>
-          <p:nvPr/>
-        </p:nvSpPr>
-        <p:spPr>
-          <a:xfrm>
-            <a:off x="658368" y="3300984"/>
-            <a:ext cx="548640" cy="548640"/>
-          </a:xfrm>
-          <a:prstGeom prst="ellipse">
-            <a:avLst/>
-          </a:prstGeom>
-          <a:solidFill>
-            <a:schemeClr val="accent1"/>
-          </a:solidFill>
-          <a:ln/>
-        </p:spPr>
-      </p:sp>
-      <p:pic>
-        <p:nvPicPr>
-          <p:cNvPr id="15" name="link-icon-3" descr="preencoded.png">    </p:cNvPr>
-          <p:cNvPicPr>
-            <a:picLocks noChangeAspect="1"/>
-          </p:cNvPicPr>
-          <p:nvPr/>
-        </p:nvPicPr>
-        <p:blipFill>
-          <a:blip r:embed="rId5"/>
-          <a:stretch>
-            <a:fillRect/>
-          </a:stretch>
-        </p:blipFill>
-        <p:spPr>
-          <a:xfrm>
-            <a:off x="795528" y="3438144"/>
-            <a:ext cx="274320" cy="274320"/>
-          </a:xfrm>
-          <a:prstGeom prst="rect">
-            <a:avLst/>
-          </a:prstGeom>
-        </p:spPr>
-      </p:pic>
-      <p:sp>
-        <p:nvSpPr>
-          <p:cNvPr id="16" name="link-text-3"/>
+          <p:cNvPr id="4" name="code"/>
           <p:cNvSpPr txBox="1"/>
           <p:nvPr/>
         </p:nvSpPr>
         <p:spPr>
           <a:xfrm>
-            <a:off x="1417320" y="3255264"/>
-            <a:ext cx="2926080" cy="640080"/>
+            <a:off x="685800" y="1188720"/>
+            <a:ext cx="7863840" cy="2377440"/>
           </a:xfrm>
           <a:prstGeom prst="rect">
             <a:avLst/>
@@ -5811,23 +5956,280 @@
           <a:ln/>
         </p:spPr>
         <p:txBody>
-          <a:bodyPr wrap="square" lIns="0" tIns="0" rIns="0" bIns="0" rtlCol="0" anchor="ctr"/>
-          <a:lstStyle/>
-          <a:p>
-            <a:pPr indent="0" marL="0">
-              <a:buNone/>
-            </a:pPr>
-            <a:r>
-              <a:rPr lang="en-US" sz="1600" b="1" dirty="0">
+          <a:bodyPr wrap="square" lIns="0" tIns="0" rIns="0" bIns="0" rtlCol="0" anchor="t"/>
+          <a:lstStyle/>
+          <a:p>
+            <a:pPr indent="0" marL="0">
+              <a:buNone/>
+            </a:pPr>
+            <a:r>
+              <a:rPr lang="en-US" sz="1000" dirty="0">
+                <a:solidFill>
+                  <a:schemeClr val="accent1"/>
+                </a:solidFill>
+                <a:latin typeface="Courier New" pitchFamily="34" charset="0"/>
+                <a:ea typeface="Courier New" pitchFamily="34" charset="-122"/>
+                <a:cs typeface="Courier New" pitchFamily="34" charset="-120"/>
+              </a:rPr>
+              <a:t># 1  Get the code, then download and unzip the Kaggle dataset</a:t>
+            </a:r>
+            <a:endParaRPr lang="en-US" sz="1000" dirty="0"/>
+          </a:p>
+          <a:p>
+            <a:pPr indent="0" marL="0">
+              <a:buNone/>
+            </a:pPr>
+            <a:r>
+              <a:rPr lang="en-US" sz="1000" dirty="0">
                 <a:solidFill>
                   <a:schemeClr val="bg1"/>
                 </a:solidFill>
-              </a:rPr>
-              <a:t>Dataset</a:t>
-            </a:r>
-            <a:endParaRPr lang="en-US" sz="1600" dirty="0"/>
-          </a:p>
-          <a:p>
+                <a:latin typeface="Courier New" pitchFamily="34" charset="0"/>
+                <a:ea typeface="Courier New" pitchFamily="34" charset="-122"/>
+                <a:cs typeface="Courier New" pitchFamily="34" charset="-120"/>
+              </a:rPr>
+              <a:t>git clone https://github.com/harshultyagi/vision_based_gripper</a:t>
+            </a:r>
+            <a:endParaRPr lang="en-US" sz="1000" dirty="0"/>
+          </a:p>
+          <a:p>
+            <a:pPr indent="0" marL="0">
+              <a:buNone/>
+            </a:pPr>
+            <a:r>
+              <a:rPr lang="en-US" sz="1000" dirty="0">
+                <a:solidFill>
+                  <a:schemeClr val="bg1"/>
+                </a:solidFill>
+                <a:latin typeface="Courier New" pitchFamily="34" charset="0"/>
+                <a:ea typeface="Courier New" pitchFamily="34" charset="-122"/>
+                <a:cs typeface="Courier New" pitchFamily="34" charset="-120"/>
+              </a:rPr>
+              <a:t>cd vision_based_gripper</a:t>
+            </a:r>
+            <a:endParaRPr lang="en-US" sz="1000" dirty="0"/>
+          </a:p>
+          <a:p>
+            <a:pPr indent="0" marL="0">
+              <a:buNone/>
+            </a:pPr>
+            <a:r>
+              <a:rPr lang="en-US" sz="1000" dirty="0">
+                <a:solidFill>
+                  <a:schemeClr val="accent1"/>
+                </a:solidFill>
+                <a:latin typeface="Courier New" pitchFamily="34" charset="0"/>
+                <a:ea typeface="Courier New" pitchFamily="34" charset="-122"/>
+                <a:cs typeface="Courier New" pitchFamily="34" charset="-120"/>
+              </a:rPr>
+              <a:t># 2  Install (Python 3.10+; an NVIDIA GPU is optional)</a:t>
+            </a:r>
+            <a:endParaRPr lang="en-US" sz="1000" dirty="0"/>
+          </a:p>
+          <a:p>
+            <a:pPr indent="0" marL="0">
+              <a:buNone/>
+            </a:pPr>
+            <a:r>
+              <a:rPr lang="en-US" sz="1000" dirty="0">
+                <a:solidFill>
+                  <a:schemeClr val="bg1"/>
+                </a:solidFill>
+                <a:latin typeface="Courier New" pitchFamily="34" charset="0"/>
+                <a:ea typeface="Courier New" pitchFamily="34" charset="-122"/>
+                <a:cs typeface="Courier New" pitchFamily="34" charset="-120"/>
+              </a:rPr>
+              <a:t>python -m venv .venv</a:t>
+            </a:r>
+            <a:endParaRPr lang="en-US" sz="1000" dirty="0"/>
+          </a:p>
+          <a:p>
+            <a:pPr indent="0" marL="0">
+              <a:buNone/>
+            </a:pPr>
+            <a:r>
+              <a:rPr lang="en-US" sz="1000" dirty="0">
+                <a:solidFill>
+                  <a:schemeClr val="accent1"/>
+                </a:solidFill>
+                <a:latin typeface="Courier New" pitchFamily="34" charset="0"/>
+                <a:ea typeface="Courier New" pitchFamily="34" charset="-122"/>
+                <a:cs typeface="Courier New" pitchFamily="34" charset="-120"/>
+              </a:rPr>
+              <a:t>#    activate it:  .venv\Scripts\activate   (Mac/Linux: source .venv/bin/activate)</a:t>
+            </a:r>
+            <a:endParaRPr lang="en-US" sz="1000" dirty="0"/>
+          </a:p>
+          <a:p>
+            <a:pPr indent="0" marL="0">
+              <a:buNone/>
+            </a:pPr>
+            <a:r>
+              <a:rPr lang="en-US" sz="1000" dirty="0">
+                <a:solidFill>
+                  <a:schemeClr val="bg1"/>
+                </a:solidFill>
+                <a:latin typeface="Courier New" pitchFamily="34" charset="0"/>
+                <a:ea typeface="Courier New" pitchFamily="34" charset="-122"/>
+                <a:cs typeface="Courier New" pitchFamily="34" charset="-120"/>
+              </a:rPr>
+              <a:t>pip install torch torchvision</a:t>
+            </a:r>
+            <a:endParaRPr lang="en-US" sz="1000" dirty="0"/>
+          </a:p>
+          <a:p>
+            <a:pPr indent="0" marL="0">
+              <a:buNone/>
+            </a:pPr>
+            <a:r>
+              <a:rPr lang="en-US" sz="1000" dirty="0">
+                <a:solidFill>
+                  <a:schemeClr val="bg1"/>
+                </a:solidFill>
+                <a:latin typeface="Courier New" pitchFamily="34" charset="0"/>
+                <a:ea typeface="Courier New" pitchFamily="34" charset="-122"/>
+                <a:cs typeface="Courier New" pitchFamily="34" charset="-120"/>
+              </a:rPr>
+              <a:t>pip install -r requirements.txt</a:t>
+            </a:r>
+            <a:endParaRPr lang="en-US" sz="1000" dirty="0"/>
+          </a:p>
+          <a:p>
+            <a:pPr indent="0" marL="0">
+              <a:buNone/>
+            </a:pPr>
+            <a:r>
+              <a:rPr lang="en-US" sz="1000" dirty="0">
+                <a:solidFill>
+                  <a:schemeClr val="bg1"/>
+                </a:solidFill>
+                <a:latin typeface="Courier New" pitchFamily="34" charset="0"/>
+                <a:ea typeface="Courier New" pitchFamily="34" charset="-122"/>
+                <a:cs typeface="Courier New" pitchFamily="34" charset="-120"/>
+              </a:rPr>
+              <a:t>pip install -e . --no-deps</a:t>
+            </a:r>
+            <a:endParaRPr lang="en-US" sz="1000" dirty="0"/>
+          </a:p>
+          <a:p>
+            <a:pPr indent="0" marL="0">
+              <a:buNone/>
+            </a:pPr>
+            <a:r>
+              <a:rPr lang="en-US" sz="1000" dirty="0">
+                <a:solidFill>
+                  <a:schemeClr val="accent1"/>
+                </a:solidFill>
+                <a:latin typeface="Courier New" pitchFamily="34" charset="0"/>
+                <a:ea typeface="Courier New" pitchFamily="34" charset="-122"/>
+                <a:cs typeface="Courier New" pitchFamily="34" charset="-120"/>
+              </a:rPr>
+              <a:t># 3  Copy the config template, then set dataset_root to the unzipped folder</a:t>
+            </a:r>
+            <a:endParaRPr lang="en-US" sz="1000" dirty="0"/>
+          </a:p>
+          <a:p>
+            <a:pPr indent="0" marL="0">
+              <a:buNone/>
+            </a:pPr>
+            <a:r>
+              <a:rPr lang="en-US" sz="1000" dirty="0">
+                <a:solidFill>
+                  <a:schemeClr val="bg1"/>
+                </a:solidFill>
+                <a:latin typeface="Courier New" pitchFamily="34" charset="0"/>
+                <a:ea typeface="Courier New" pitchFamily="34" charset="-122"/>
+                <a:cs typeface="Courier New" pitchFamily="34" charset="-120"/>
+              </a:rPr>
+              <a:t>copy configs\local.example.yaml configs\local.yaml      (Mac/Linux: cp)</a:t>
+            </a:r>
+            <a:endParaRPr lang="en-US" sz="1000" dirty="0"/>
+          </a:p>
+          <a:p>
+            <a:pPr indent="0" marL="0">
+              <a:buNone/>
+            </a:pPr>
+            <a:r>
+              <a:rPr lang="en-US" sz="1000" dirty="0">
+                <a:solidFill>
+                  <a:schemeClr val="accent1"/>
+                </a:solidFill>
+                <a:latin typeface="Courier New" pitchFamily="34" charset="0"/>
+                <a:ea typeface="Courier New" pitchFamily="34" charset="-122"/>
+                <a:cs typeface="Courier New" pitchFamily="34" charset="-120"/>
+              </a:rPr>
+              <a:t># 4  Run the trained models (no training needed)</a:t>
+            </a:r>
+            <a:endParaRPr lang="en-US" sz="1000" dirty="0"/>
+          </a:p>
+          <a:p>
+            <a:pPr indent="0" marL="0">
+              <a:buNone/>
+            </a:pPr>
+            <a:r>
+              <a:rPr lang="en-US" sz="1000" dirty="0">
+                <a:solidFill>
+                  <a:schemeClr val="bg1"/>
+                </a:solidFill>
+                <a:latin typeface="Courier New" pitchFamily="34" charset="0"/>
+                <a:ea typeface="Courier New" pitchFamily="34" charset="-122"/>
+                <a:cs typeface="Courier New" pitchFamily="34" charset="-120"/>
+              </a:rPr>
+              <a:t>python scripts/evaluate.py --weights models/grconvnet_rgbd_image.pt --split test</a:t>
+            </a:r>
+            <a:endParaRPr lang="en-US" sz="1000" dirty="0"/>
+          </a:p>
+          <a:p>
+            <a:pPr indent="0" marL="0">
+              <a:buNone/>
+            </a:pPr>
+            <a:r>
+              <a:rPr lang="en-US" sz="1000" dirty="0">
+                <a:solidFill>
+                  <a:schemeClr val="bg1"/>
+                </a:solidFill>
+                <a:latin typeface="Courier New" pitchFamily="34" charset="0"/>
+                <a:ea typeface="Courier New" pitchFamily="34" charset="-122"/>
+                <a:cs typeface="Courier New" pitchFamily="34" charset="-120"/>
+              </a:rPr>
+              <a:t>python scripts/predict.py --checkpoint models/grconvnet_rgb_image.pt --rgb DATA/01/pcd0101r.png</a:t>
+            </a:r>
+            <a:endParaRPr lang="en-US" sz="1000" dirty="0"/>
+          </a:p>
+        </p:txBody>
+      </p:sp>
+      <p:sp>
+        <p:nvSpPr>
+          <p:cNvPr id="5" name="run-output"/>
+          <p:cNvSpPr txBox="1"/>
+          <p:nvPr/>
+        </p:nvSpPr>
+        <p:spPr>
+          <a:xfrm>
+            <a:off x="457200" y="3840480"/>
+            <a:ext cx="8229600" cy="731520"/>
+          </a:xfrm>
+          <a:prstGeom prst="rect">
+            <a:avLst/>
+          </a:prstGeom>
+          <a:noFill/>
+          <a:ln/>
+        </p:spPr>
+        <p:txBody>
+          <a:bodyPr wrap="square" lIns="0" tIns="0" rIns="0" bIns="0" rtlCol="0" anchor="t"/>
+          <a:lstStyle/>
+          <a:p>
+            <a:pPr indent="0" marL="0">
+              <a:buNone/>
+            </a:pPr>
+            <a:r>
+              <a:rPr lang="en-US" sz="1200" b="1" dirty="0">
+                <a:solidFill>
+                  <a:schemeClr val="bg1"/>
+                </a:solidFill>
+              </a:rPr>
+              <a:t>What you get: </a:t>
+            </a:r>
             <a:pPr indent="0" marL="0">
               <a:buNone/>
             </a:pPr>
@@ -5837,86 +6239,7 @@
                   <a:schemeClr val="bg2"/>
                 </a:solidFill>
               </a:rPr>
-              <a:t>Cornell Grasping Dataset (Kaggle copy)</a:t>
-            </a:r>
-            <a:endParaRPr lang="en-US" sz="1600" dirty="0"/>
-          </a:p>
-        </p:txBody>
-      </p:sp>
-      <p:sp>
-        <p:nvSpPr>
-          <p:cNvPr id="17" name="link-url-3"/>
-          <p:cNvSpPr txBox="1"/>
-          <p:nvPr/>
-        </p:nvSpPr>
-        <p:spPr>
-          <a:xfrm>
-            <a:off x="4389120" y="3255264"/>
-            <a:ext cx="4114800" cy="640080"/>
-          </a:xfrm>
-          <a:prstGeom prst="rect">
-            <a:avLst/>
-          </a:prstGeom>
-          <a:noFill/>
-          <a:ln/>
-        </p:spPr>
-        <p:txBody>
-          <a:bodyPr wrap="square" lIns="0" tIns="0" rIns="0" bIns="0" rtlCol="0" anchor="ctr"/>
-          <a:lstStyle/>
-          <a:p>
-            <a:pPr algn="r" indent="0" marL="0">
-              <a:buNone/>
-            </a:pPr>
-            <a:r>
-              <a:rPr lang="en-US" sz="1300" u="sng" dirty="0">
-                <a:solidFill>
-                  <a:schemeClr val="accent1"/>
-                </a:solidFill>
-                <a:hlinkClick r:id="rId6" invalidUrl="" action="" tgtFrame="" tooltip="https://www.kaggle.com/datasets/oneoneliu/cornell-grasp" history="1" highlightClick="0" endSnd="0">
-                  <a:extLst>
-                    <a:ext uri="{A12FA001-AC4F-418D-AE19-62706E023703}">
-                      <ahyp:hlinkClr xmlns:ahyp="http://schemas.microsoft.com/office/drawing/2018/hyperlinkcolor" val="tx"/>
-                    </a:ext>
-                  </a:extLst>
-                </a:hlinkClick>
-              </a:rPr>
-              <a:t>kaggle.com/datasets/oneoneliu/cornell-grasp</a:t>
-            </a:r>
-            <a:endParaRPr lang="en-US" sz="1300" dirty="0"/>
-          </a:p>
-        </p:txBody>
-      </p:sp>
-      <p:sp>
-        <p:nvSpPr>
-          <p:cNvPr id="18" name="limits"/>
-          <p:cNvSpPr txBox="1"/>
-          <p:nvPr/>
-        </p:nvSpPr>
-        <p:spPr>
-          <a:xfrm>
-            <a:off x="457200" y="4343400"/>
-            <a:ext cx="8229600" cy="320040"/>
-          </a:xfrm>
-          <a:prstGeom prst="rect">
-            <a:avLst/>
-          </a:prstGeom>
-          <a:noFill/>
-          <a:ln/>
-        </p:spPr>
-        <p:txBody>
-          <a:bodyPr wrap="square" lIns="0" tIns="0" rIns="0" bIns="0" rtlCol="0" anchor="ctr"/>
-          <a:lstStyle/>
-          <a:p>
-            <a:pPr indent="0" marL="0">
-              <a:buNone/>
-            </a:pPr>
-            <a:r>
-              <a:rPr lang="en-US" sz="1200" i="1" dirty="0">
-                <a:solidFill>
-                  <a:schemeClr val="accent5"/>
-                </a:solidFill>
-              </a:rPr>
-              <a:t>Limits: single-object scenes · 2-D image grasps only · not yet tested on a real robot</a:t>
+              <a:t>the evaluate command prints test top-1 accuracy 0.886 (88.6%, matching this deck) in about 25 s on a CPU; predict prints the ranked grasps for a scene (centre, angle, width, score, contact points). DATA = the dataset folder. Optional: python app/app.py opens the web UI.</a:t>
             </a:r>
             <a:endParaRPr lang="en-US" sz="1200" dirty="0"/>
           </a:p>

</xml_diff>